<commit_message>
Add Tier C corpus validation and written deck generation
- Implemented validation tests for the corpus in `validate.test.ts` to ensure all committed decks are error-free and adhere to expected standards.
- Created a script `build-written.ts` to generate Tier C decks from the writer in `packages/opc`, including a manifest for tracking.
- Added tests in `decks.test.ts` to verify the integrity and correctness of the written decks against their source.
- Defined the structure and details of the written decks in `decks.ts`, ensuring consistency with other tiers and documenting the normalization process.
</commit_message>
<xml_diff>
--- a/corpus/decks/a20-tables.pptx
+++ b/corpus/decks/a20-tables.pptx
@@ -1199,9 +1199,11 @@
               <a:tblPr rtl="0" firstRow="1" lastRow="1" firstCol="1" lastCol="1" bandRow="1" bandCol="1">
                 <a:tableStyle styleId="{1B1D64F0-0000-4000-8000-0000000A200A}" styleName="PPTX Studio Corpus Probe">
                   <a:tblBg>
-                    <a:solidFill>
-                      <a:schemeClr val="bg1"/>
-                    </a:solidFill>
+                    <a:fill>
+                      <a:solidFill>
+                        <a:schemeClr val="bg1"/>
+                      </a:solidFill>
+                    </a:fill>
                   </a:tblBg>
                   <a:wholeTbl>
                     <a:tcTxStyle b="def" i="def">
@@ -1267,9 +1269,11 @@
                           </a:ln>
                         </a:insideV>
                       </a:tcBdr>
-                      <a:solidFill>
-                        <a:schemeClr val="bg1"/>
-                      </a:solidFill>
+                      <a:fill>
+                        <a:solidFill>
+                          <a:schemeClr val="bg1"/>
+                        </a:solidFill>
+                      </a:fill>
                     </a:tcStyle>
                   </a:wholeTbl>
                   <a:band1H>
@@ -1318,11 +1322,13 @@
                           </a:ln>
                         </a:insideV>
                       </a:tcBdr>
-                      <a:solidFill>
-                        <a:schemeClr val="accent1">
-                          <a:alpha val="20000"/>
-                        </a:schemeClr>
-                      </a:solidFill>
+                      <a:fill>
+                        <a:solidFill>
+                          <a:schemeClr val="accent1">
+                            <a:alpha val="20000"/>
+                          </a:schemeClr>
+                        </a:solidFill>
+                      </a:fill>
                     </a:tcStyle>
                   </a:band1H>
                   <a:band2H>
@@ -1371,9 +1377,11 @@
                           </a:ln>
                         </a:insideV>
                       </a:tcBdr>
-                      <a:solidFill>
-                        <a:schemeClr val="bg1"/>
-                      </a:solidFill>
+                      <a:fill>
+                        <a:solidFill>
+                          <a:schemeClr val="bg1"/>
+                        </a:solidFill>
+                      </a:fill>
                     </a:tcStyle>
                   </a:band2H>
                   <a:band1V>
@@ -1422,11 +1430,13 @@
                           </a:ln>
                         </a:insideV>
                       </a:tcBdr>
-                      <a:solidFill>
-                        <a:schemeClr val="accent3">
-                          <a:alpha val="15000"/>
-                        </a:schemeClr>
-                      </a:solidFill>
+                      <a:fill>
+                        <a:solidFill>
+                          <a:schemeClr val="accent3">
+                            <a:alpha val="15000"/>
+                          </a:schemeClr>
+                        </a:solidFill>
+                      </a:fill>
                     </a:tcStyle>
                   </a:band1V>
                   <a:lastCol>
@@ -1478,11 +1488,13 @@
                           </a:ln>
                         </a:insideV>
                       </a:tcBdr>
-                      <a:solidFill>
-                        <a:schemeClr val="accent6">
-                          <a:alpha val="30000"/>
-                        </a:schemeClr>
-                      </a:solidFill>
+                      <a:fill>
+                        <a:solidFill>
+                          <a:schemeClr val="accent6">
+                            <a:alpha val="30000"/>
+                          </a:schemeClr>
+                        </a:solidFill>
+                      </a:fill>
                     </a:tcStyle>
                   </a:lastCol>
                   <a:firstCol>
@@ -1534,11 +1546,13 @@
                           </a:ln>
                         </a:insideV>
                       </a:tcBdr>
-                      <a:solidFill>
-                        <a:schemeClr val="accent2">
-                          <a:alpha val="30000"/>
-                        </a:schemeClr>
-                      </a:solidFill>
+                      <a:fill>
+                        <a:solidFill>
+                          <a:schemeClr val="accent2">
+                            <a:alpha val="30000"/>
+                          </a:schemeClr>
+                        </a:solidFill>
+                      </a:fill>
                     </a:tcStyle>
                   </a:firstCol>
                   <a:lastRow>
@@ -1590,11 +1604,13 @@
                           </a:ln>
                         </a:insideV>
                       </a:tcBdr>
-                      <a:solidFill>
-                        <a:schemeClr val="accent4">
-                          <a:alpha val="25000"/>
-                        </a:schemeClr>
-                      </a:solidFill>
+                      <a:fill>
+                        <a:solidFill>
+                          <a:schemeClr val="accent4">
+                            <a:alpha val="25000"/>
+                          </a:schemeClr>
+                        </a:solidFill>
+                      </a:fill>
                     </a:tcStyle>
                   </a:lastRow>
                   <a:seCell>
@@ -1643,9 +1659,11 @@
                           </a:ln>
                         </a:insideV>
                       </a:tcBdr>
-                      <a:solidFill>
-                        <a:srgbClr val="FFE699"/>
-                      </a:solidFill>
+                      <a:fill>
+                        <a:solidFill>
+                          <a:srgbClr val="FFE699"/>
+                        </a:solidFill>
+                      </a:fill>
                     </a:tcStyle>
                   </a:seCell>
                   <a:swCell>
@@ -1694,9 +1712,11 @@
                           </a:ln>
                         </a:insideV>
                       </a:tcBdr>
-                      <a:solidFill>
-                        <a:srgbClr val="C5E0B4"/>
-                      </a:solidFill>
+                      <a:fill>
+                        <a:solidFill>
+                          <a:srgbClr val="C5E0B4"/>
+                        </a:solidFill>
+                      </a:fill>
                     </a:tcStyle>
                   </a:swCell>
                   <a:firstRow>
@@ -1748,9 +1768,11 @@
                           </a:ln>
                         </a:insideV>
                       </a:tcBdr>
-                      <a:solidFill>
-                        <a:schemeClr val="accent1"/>
-                      </a:solidFill>
+                      <a:fill>
+                        <a:solidFill>
+                          <a:schemeClr val="accent1"/>
+                        </a:solidFill>
+                      </a:fill>
                     </a:tcStyle>
                   </a:firstRow>
                   <a:neCell>
@@ -1799,9 +1821,11 @@
                           </a:ln>
                         </a:insideV>
                       </a:tcBdr>
-                      <a:solidFill>
-                        <a:srgbClr val="F8CBAD"/>
-                      </a:solidFill>
+                      <a:fill>
+                        <a:solidFill>
+                          <a:srgbClr val="F8CBAD"/>
+                        </a:solidFill>
+                      </a:fill>
                     </a:tcStyle>
                   </a:neCell>
                   <a:nwCell>
@@ -1850,9 +1874,11 @@
                           </a:ln>
                         </a:insideV>
                       </a:tcBdr>
-                      <a:solidFill>
-                        <a:srgbClr val="B4C7E7"/>
-                      </a:solidFill>
+                      <a:fill>
+                        <a:solidFill>
+                          <a:srgbClr val="B4C7E7"/>
+                        </a:solidFill>
+                      </a:fill>
                     </a:tcStyle>
                   </a:nwCell>
                 </a:tableStyle>

</xml_diff>